<commit_message>
Finish stats case studies: capstone 27, final summary deck, fixes to 18-26
- Case 27: README and 12-slide deck; fix raw-vs-adjusted claims table (coefficient selected by name) and employment-label count in the cleaning log
- Final summary: 8-slide playbook deck builder
- Cases 25, 26: figure layout fixes (decomposition size, arrivals legend), rebuilt decks
- PROGRESS.md: all 27 cases and the final summary marked complete

Co-Authored-By: Claude Sonnet 5.5 <noreply@anthropic.com>
</commit_message>
<xml_diff>
--- a/stats_case_study/case_studies/25_digital_payments_time_series/presentation/case_study_presentation.pptx
+++ b/stats_case_study/case_studies/25_digital_payments_time_series/presentation/case_study_presentation.pptx
@@ -5869,8 +5869,8 @@
         </p:blipFill>
         <p:spPr>
           <a:xfrm>
-            <a:off x="3796692" y="1554480"/>
-            <a:ext cx="4598311" cy="3794760"/>
+            <a:off x="2263803" y="1554480"/>
+            <a:ext cx="7664089" cy="3794760"/>
           </a:xfrm>
           <a:prstGeom prst="rect">
             <a:avLst/>
@@ -6019,7 +6019,7 @@
                 </a:solidFill>
                 <a:latin typeface="Calibri"/>
               </a:rPr>
-              <a:t>Growth is not 20%: it fell every year after the 2021 rebound</a:t>
+              <a:t>Growth is not 20%: it has slowed since the 2021 rebound</a:t>
             </a:r>
           </a:p>
         </p:txBody>

</xml_diff>